<commit_message>
Improve chapter 3 process diagram slide design
Co-authored-by: sazmanfava854-sudo <sazmanfava854-sudo@users.noreply.github.com>
</commit_message>
<xml_diff>
--- a/artifacts/chapter3-process-diagram.pptx
+++ b/artifacts/chapter3-process-diagram.pptx
@@ -3084,7 +3084,7 @@
     <p:bg>
       <p:bgPr>
         <a:solidFill>
-          <a:srgbClr val="F7F8FA"/>
+          <a:srgbClr val="FAFBFD"/>
         </a:solidFill>
         <a:effectLst/>
       </p:bgPr>
@@ -3098,57 +3098,20 @@
       <p:grpSpPr/>
       <p:sp>
         <p:nvSpPr>
-          <p:cNvPr id="2" name="TextBox 1"/>
-          <p:cNvSpPr txBox="1"/>
+          <p:cNvPr id="2" name="Rectangle 1"/>
+          <p:cNvSpPr/>
           <p:nvPr/>
         </p:nvSpPr>
         <p:spPr>
           <a:xfrm>
-            <a:off x="457200" y="365760"/>
-            <a:ext cx="11247120" cy="594360"/>
+            <a:off x="10881360" y="475488"/>
+            <a:ext cx="64008" cy="530352"/>
           </a:xfrm>
           <a:prstGeom prst="rect">
             <a:avLst/>
           </a:prstGeom>
-          <a:noFill/>
-        </p:spPr>
-        <p:txBody>
-          <a:bodyPr wrap="square" anchor="ctr">
-            <a:spAutoFit/>
-          </a:bodyPr>
-          <a:lstStyle/>
-          <a:p>
-            <a:pPr algn="ctr"/>
-            <a:r>
-              <a:rPr sz="3200" b="1">
-                <a:solidFill>
-                  <a:srgbClr val="1A1A2E"/>
-                </a:solidFill>
-                <a:latin typeface="B Nazanin"/>
-              </a:rPr>
-              <a:t>فرایند انتخاب و رتبه‌بندی فناوری‌ها</a:t>
-            </a:r>
-          </a:p>
-        </p:txBody>
-      </p:sp>
-      <p:sp>
-        <p:nvSpPr>
-          <p:cNvPr id="3" name="Rounded Rectangle 2"/>
-          <p:cNvSpPr/>
-          <p:nvPr/>
-        </p:nvSpPr>
-        <p:spPr>
-          <a:xfrm>
-            <a:off x="8732520" y="2423160"/>
-            <a:ext cx="1965960" cy="1645920"/>
-          </a:xfrm>
-          <a:prstGeom prst="roundRect">
-            <a:avLst>
-              <a:gd name="adj" fmla="val 8000"/>
-            </a:avLst>
-          </a:prstGeom>
           <a:solidFill>
-            <a:srgbClr val="2F6FED"/>
+            <a:srgbClr val="2563EB"/>
           </a:solidFill>
           <a:ln>
             <a:noFill/>
@@ -3178,14 +3141,14 @@
       </p:sp>
       <p:sp>
         <p:nvSpPr>
-          <p:cNvPr id="4" name="TextBox 3"/>
+          <p:cNvPr id="3" name="TextBox 2"/>
           <p:cNvSpPr txBox="1"/>
           <p:nvPr/>
         </p:nvSpPr>
         <p:spPr>
           <a:xfrm>
-            <a:off x="8732520" y="2834640"/>
-            <a:ext cx="1965960" cy="365760"/>
+            <a:off x="731520" y="411480"/>
+            <a:ext cx="10058400" cy="566928"/>
           </a:xfrm>
           <a:prstGeom prst="rect">
             <a:avLst/>
@@ -3193,14 +3156,258 @@
           <a:noFill/>
         </p:spPr>
         <p:txBody>
-          <a:bodyPr wrap="square" anchor="ctr">
+          <a:bodyPr wrap="square" anchor="ctr" lIns="101600" rIns="101600">
             <a:spAutoFit/>
           </a:bodyPr>
           <a:lstStyle/>
           <a:p>
+            <a:pPr algn="r"/>
+            <a:r>
+              <a:rPr sz="3000" b="1">
+                <a:solidFill>
+                  <a:srgbClr val="0F172A"/>
+                </a:solidFill>
+                <a:latin typeface="B Nazanin"/>
+              </a:rPr>
+              <a:t>فرایند انتخاب و رتبه‌بندی فناوری‌ها</a:t>
+            </a:r>
+          </a:p>
+        </p:txBody>
+      </p:sp>
+      <p:sp>
+        <p:nvSpPr>
+          <p:cNvPr id="4" name="TextBox 3"/>
+          <p:cNvSpPr txBox="1"/>
+          <p:nvPr/>
+        </p:nvSpPr>
+        <p:spPr>
+          <a:xfrm>
+            <a:off x="731520" y="932688"/>
+            <a:ext cx="10058400" cy="320040"/>
+          </a:xfrm>
+          <a:prstGeom prst="rect">
+            <a:avLst/>
+          </a:prstGeom>
+          <a:noFill/>
+        </p:spPr>
+        <p:txBody>
+          <a:bodyPr wrap="square" anchor="ctr" lIns="101600" rIns="101600">
+            <a:spAutoFit/>
+          </a:bodyPr>
+          <a:lstStyle/>
+          <a:p>
+            <a:pPr algn="r"/>
+            <a:r>
+              <a:rPr sz="1400" b="0">
+                <a:solidFill>
+                  <a:srgbClr val="64748B"/>
+                </a:solidFill>
+                <a:latin typeface="B Nazanin"/>
+              </a:rPr>
+              <a:t>چارچوب چهارمرحله‌ای مدل پیشنهادی</a:t>
+            </a:r>
+          </a:p>
+        </p:txBody>
+      </p:sp>
+      <p:sp>
+        <p:nvSpPr>
+          <p:cNvPr id="5" name="Rectangle 4"/>
+          <p:cNvSpPr/>
+          <p:nvPr/>
+        </p:nvSpPr>
+        <p:spPr>
+          <a:xfrm>
+            <a:off x="731520" y="1353312"/>
+            <a:ext cx="10725912" cy="12700"/>
+          </a:xfrm>
+          <a:prstGeom prst="rect">
+            <a:avLst/>
+          </a:prstGeom>
+          <a:solidFill>
+            <a:srgbClr val="E2E8F0"/>
+          </a:solidFill>
+          <a:ln>
+            <a:noFill/>
+          </a:ln>
+        </p:spPr>
+        <p:style>
+          <a:lnRef idx="1">
+            <a:schemeClr val="accent1"/>
+          </a:lnRef>
+          <a:fillRef idx="3">
+            <a:schemeClr val="accent1"/>
+          </a:fillRef>
+          <a:effectRef idx="2">
+            <a:schemeClr val="accent1"/>
+          </a:effectRef>
+          <a:fontRef idx="minor">
+            <a:schemeClr val="lt1"/>
+          </a:fontRef>
+        </p:style>
+        <p:txBody>
+          <a:bodyPr rtlCol="0" anchor="ctr"/>
+          <a:lstStyle/>
+          <a:p>
             <a:pPr algn="ctr"/>
-            <a:r>
-              <a:rPr sz="2200" b="1">
+          </a:p>
+        </p:txBody>
+      </p:sp>
+      <p:sp>
+        <p:nvSpPr>
+          <p:cNvPr id="6" name="Rectangle 5"/>
+          <p:cNvSpPr/>
+          <p:nvPr/>
+        </p:nvSpPr>
+        <p:spPr>
+          <a:xfrm>
+            <a:off x="9710928" y="2779776"/>
+            <a:ext cx="2057400" cy="1600200"/>
+          </a:xfrm>
+          <a:prstGeom prst="rect">
+            <a:avLst/>
+          </a:prstGeom>
+          <a:solidFill>
+            <a:srgbClr val="D1D9E6"/>
+          </a:solidFill>
+          <a:ln>
+            <a:noFill/>
+          </a:ln>
+        </p:spPr>
+        <p:style>
+          <a:lnRef idx="1">
+            <a:schemeClr val="accent1"/>
+          </a:lnRef>
+          <a:fillRef idx="3">
+            <a:schemeClr val="accent1"/>
+          </a:fillRef>
+          <a:effectRef idx="2">
+            <a:schemeClr val="accent1"/>
+          </a:effectRef>
+          <a:fontRef idx="minor">
+            <a:schemeClr val="lt1"/>
+          </a:fontRef>
+        </p:style>
+        <p:txBody>
+          <a:bodyPr rtlCol="0" anchor="ctr"/>
+          <a:lstStyle/>
+          <a:p>
+            <a:pPr algn="ctr"/>
+          </a:p>
+        </p:txBody>
+      </p:sp>
+      <p:sp>
+        <p:nvSpPr>
+          <p:cNvPr id="7" name="Rectangle 6"/>
+          <p:cNvSpPr/>
+          <p:nvPr/>
+        </p:nvSpPr>
+        <p:spPr>
+          <a:xfrm>
+            <a:off x="9674352" y="2743200"/>
+            <a:ext cx="2057400" cy="1600200"/>
+          </a:xfrm>
+          <a:prstGeom prst="rect">
+            <a:avLst/>
+          </a:prstGeom>
+          <a:solidFill>
+            <a:srgbClr val="2563EB"/>
+          </a:solidFill>
+          <a:ln w="9525">
+            <a:solidFill>
+              <a:srgbClr val="1E40AF"/>
+            </a:solidFill>
+          </a:ln>
+        </p:spPr>
+        <p:style>
+          <a:lnRef idx="1">
+            <a:schemeClr val="accent1"/>
+          </a:lnRef>
+          <a:fillRef idx="3">
+            <a:schemeClr val="accent1"/>
+          </a:fillRef>
+          <a:effectRef idx="2">
+            <a:schemeClr val="accent1"/>
+          </a:effectRef>
+          <a:fontRef idx="minor">
+            <a:schemeClr val="lt1"/>
+          </a:fontRef>
+        </p:style>
+        <p:txBody>
+          <a:bodyPr rtlCol="0" anchor="ctr"/>
+          <a:lstStyle/>
+          <a:p>
+            <a:pPr algn="ctr"/>
+          </a:p>
+        </p:txBody>
+      </p:sp>
+      <p:sp>
+        <p:nvSpPr>
+          <p:cNvPr id="8" name="Rectangle 7"/>
+          <p:cNvSpPr/>
+          <p:nvPr/>
+        </p:nvSpPr>
+        <p:spPr>
+          <a:xfrm>
+            <a:off x="9674352" y="2743200"/>
+            <a:ext cx="2057400" cy="45720"/>
+          </a:xfrm>
+          <a:prstGeom prst="rect">
+            <a:avLst/>
+          </a:prstGeom>
+          <a:solidFill>
+            <a:srgbClr val="60A5FA"/>
+          </a:solidFill>
+          <a:ln>
+            <a:noFill/>
+          </a:ln>
+        </p:spPr>
+        <p:style>
+          <a:lnRef idx="1">
+            <a:schemeClr val="accent1"/>
+          </a:lnRef>
+          <a:fillRef idx="3">
+            <a:schemeClr val="accent1"/>
+          </a:fillRef>
+          <a:effectRef idx="2">
+            <a:schemeClr val="accent1"/>
+          </a:effectRef>
+          <a:fontRef idx="minor">
+            <a:schemeClr val="lt1"/>
+          </a:fontRef>
+        </p:style>
+        <p:txBody>
+          <a:bodyPr rtlCol="0" anchor="ctr"/>
+          <a:lstStyle/>
+          <a:p>
+            <a:pPr algn="ctr"/>
+          </a:p>
+        </p:txBody>
+      </p:sp>
+      <p:sp>
+        <p:nvSpPr>
+          <p:cNvPr id="9" name="TextBox 8"/>
+          <p:cNvSpPr txBox="1"/>
+          <p:nvPr/>
+        </p:nvSpPr>
+        <p:spPr>
+          <a:xfrm>
+            <a:off x="9674352" y="3044952"/>
+            <a:ext cx="2057400" cy="384048"/>
+          </a:xfrm>
+          <a:prstGeom prst="rect">
+            <a:avLst/>
+          </a:prstGeom>
+          <a:noFill/>
+        </p:spPr>
+        <p:txBody>
+          <a:bodyPr wrap="square" anchor="ctr" lIns="101600" rIns="101600">
+            <a:spAutoFit/>
+          </a:bodyPr>
+          <a:lstStyle/>
+          <a:p>
+            <a:pPr algn="ctr"/>
+            <a:r>
+              <a:rPr sz="2000" b="1">
                 <a:solidFill>
                   <a:srgbClr val="FFFFFF"/>
                 </a:solidFill>
@@ -3213,14 +3420,14 @@
       </p:sp>
       <p:sp>
         <p:nvSpPr>
-          <p:cNvPr id="5" name="TextBox 4"/>
+          <p:cNvPr id="10" name="TextBox 9"/>
           <p:cNvSpPr txBox="1"/>
           <p:nvPr/>
         </p:nvSpPr>
         <p:spPr>
           <a:xfrm>
-            <a:off x="8732520" y="3291840"/>
-            <a:ext cx="1965960" cy="292608"/>
+            <a:off x="9674352" y="3447288"/>
+            <a:ext cx="2057400" cy="502920"/>
           </a:xfrm>
           <a:prstGeom prst="rect">
             <a:avLst/>
@@ -3228,77 +3435,40 @@
           <a:noFill/>
         </p:spPr>
         <p:txBody>
-          <a:bodyPr wrap="square" anchor="ctr">
+          <a:bodyPr wrap="square" anchor="ctr" lIns="101600" rIns="101600">
             <a:spAutoFit/>
           </a:bodyPr>
           <a:lstStyle/>
           <a:p>
             <a:pPr algn="ctr"/>
             <a:r>
-              <a:rPr sz="1600" b="0">
+              <a:rPr sz="1400" b="0">
                 <a:solidFill>
-                  <a:srgbClr val="FFFFFF"/>
+                  <a:srgbClr val="DBEAFE"/>
                 </a:solidFill>
                 <a:latin typeface="B Nazanin"/>
               </a:rPr>
-              <a:t>گروه‌بندی فناوری‌های</a:t>
-            </a:r>
-          </a:p>
-        </p:txBody>
-      </p:sp>
-      <p:sp>
-        <p:nvSpPr>
-          <p:cNvPr id="6" name="TextBox 5"/>
-          <p:cNvSpPr txBox="1"/>
+              <a:t>گروه‌بندی فناوری‌های مشابه</a:t>
+            </a:r>
+          </a:p>
+        </p:txBody>
+      </p:sp>
+      <p:sp>
+        <p:nvSpPr>
+          <p:cNvPr id="11" name="Rectangle 10"/>
+          <p:cNvSpPr/>
           <p:nvPr/>
         </p:nvSpPr>
         <p:spPr>
           <a:xfrm>
-            <a:off x="8732520" y="3566160"/>
-            <a:ext cx="1965960" cy="292608"/>
+            <a:off x="7306056" y="2779776"/>
+            <a:ext cx="2057400" cy="1600200"/>
           </a:xfrm>
           <a:prstGeom prst="rect">
             <a:avLst/>
           </a:prstGeom>
-          <a:noFill/>
-        </p:spPr>
-        <p:txBody>
-          <a:bodyPr wrap="square" anchor="ctr">
-            <a:spAutoFit/>
-          </a:bodyPr>
-          <a:lstStyle/>
-          <a:p>
-            <a:pPr algn="ctr"/>
-            <a:r>
-              <a:rPr sz="1600" b="0">
-                <a:solidFill>
-                  <a:srgbClr val="FFFFFF"/>
-                </a:solidFill>
-                <a:latin typeface="B Nazanin"/>
-              </a:rPr>
-              <a:t>مشابه</a:t>
-            </a:r>
-          </a:p>
-        </p:txBody>
-      </p:sp>
-      <p:sp>
-        <p:nvSpPr>
-          <p:cNvPr id="7" name="Rounded Rectangle 6"/>
-          <p:cNvSpPr/>
-          <p:nvPr/>
-        </p:nvSpPr>
-        <p:spPr>
-          <a:xfrm>
-            <a:off x="6355080" y="2423160"/>
-            <a:ext cx="1965960" cy="1645920"/>
-          </a:xfrm>
-          <a:prstGeom prst="roundRect">
-            <a:avLst>
-              <a:gd name="adj" fmla="val 8000"/>
-            </a:avLst>
-          </a:prstGeom>
           <a:solidFill>
-            <a:srgbClr val="2F6FED"/>
+            <a:srgbClr val="D1D9E6"/>
           </a:solidFill>
           <a:ln>
             <a:noFill/>
@@ -3328,14 +3498,102 @@
       </p:sp>
       <p:sp>
         <p:nvSpPr>
-          <p:cNvPr id="8" name="TextBox 7"/>
+          <p:cNvPr id="12" name="Rectangle 11"/>
+          <p:cNvSpPr/>
+          <p:nvPr/>
+        </p:nvSpPr>
+        <p:spPr>
+          <a:xfrm>
+            <a:off x="7269480" y="2743200"/>
+            <a:ext cx="2057400" cy="1600200"/>
+          </a:xfrm>
+          <a:prstGeom prst="rect">
+            <a:avLst/>
+          </a:prstGeom>
+          <a:solidFill>
+            <a:srgbClr val="2563EB"/>
+          </a:solidFill>
+          <a:ln w="9525">
+            <a:solidFill>
+              <a:srgbClr val="1E40AF"/>
+            </a:solidFill>
+          </a:ln>
+        </p:spPr>
+        <p:style>
+          <a:lnRef idx="1">
+            <a:schemeClr val="accent1"/>
+          </a:lnRef>
+          <a:fillRef idx="3">
+            <a:schemeClr val="accent1"/>
+          </a:fillRef>
+          <a:effectRef idx="2">
+            <a:schemeClr val="accent1"/>
+          </a:effectRef>
+          <a:fontRef idx="minor">
+            <a:schemeClr val="lt1"/>
+          </a:fontRef>
+        </p:style>
+        <p:txBody>
+          <a:bodyPr rtlCol="0" anchor="ctr"/>
+          <a:lstStyle/>
+          <a:p>
+            <a:pPr algn="ctr"/>
+          </a:p>
+        </p:txBody>
+      </p:sp>
+      <p:sp>
+        <p:nvSpPr>
+          <p:cNvPr id="13" name="Rectangle 12"/>
+          <p:cNvSpPr/>
+          <p:nvPr/>
+        </p:nvSpPr>
+        <p:spPr>
+          <a:xfrm>
+            <a:off x="7269480" y="2743200"/>
+            <a:ext cx="2057400" cy="45720"/>
+          </a:xfrm>
+          <a:prstGeom prst="rect">
+            <a:avLst/>
+          </a:prstGeom>
+          <a:solidFill>
+            <a:srgbClr val="60A5FA"/>
+          </a:solidFill>
+          <a:ln>
+            <a:noFill/>
+          </a:ln>
+        </p:spPr>
+        <p:style>
+          <a:lnRef idx="1">
+            <a:schemeClr val="accent1"/>
+          </a:lnRef>
+          <a:fillRef idx="3">
+            <a:schemeClr val="accent1"/>
+          </a:fillRef>
+          <a:effectRef idx="2">
+            <a:schemeClr val="accent1"/>
+          </a:effectRef>
+          <a:fontRef idx="minor">
+            <a:schemeClr val="lt1"/>
+          </a:fontRef>
+        </p:style>
+        <p:txBody>
+          <a:bodyPr rtlCol="0" anchor="ctr"/>
+          <a:lstStyle/>
+          <a:p>
+            <a:pPr algn="ctr"/>
+          </a:p>
+        </p:txBody>
+      </p:sp>
+      <p:sp>
+        <p:nvSpPr>
+          <p:cNvPr id="14" name="TextBox 13"/>
           <p:cNvSpPr txBox="1"/>
           <p:nvPr/>
         </p:nvSpPr>
         <p:spPr>
           <a:xfrm>
-            <a:off x="6355080" y="2834640"/>
-            <a:ext cx="1965960" cy="365760"/>
+            <a:off x="7269480" y="3044952"/>
+            <a:ext cx="2057400" cy="384048"/>
           </a:xfrm>
           <a:prstGeom prst="rect">
             <a:avLst/>
@@ -3343,7 +3601,7 @@
           <a:noFill/>
         </p:spPr>
         <p:txBody>
-          <a:bodyPr wrap="square" anchor="ctr">
+          <a:bodyPr wrap="square" anchor="ctr" lIns="101600" rIns="101600">
             <a:spAutoFit/>
           </a:bodyPr>
           <a:lstStyle/>
@@ -3363,14 +3621,14 @@
       </p:sp>
       <p:sp>
         <p:nvSpPr>
-          <p:cNvPr id="9" name="TextBox 8"/>
+          <p:cNvPr id="15" name="TextBox 14"/>
           <p:cNvSpPr txBox="1"/>
           <p:nvPr/>
         </p:nvSpPr>
         <p:spPr>
           <a:xfrm>
-            <a:off x="6355080" y="3291840"/>
-            <a:ext cx="1965960" cy="292608"/>
+            <a:off x="7269480" y="3447288"/>
+            <a:ext cx="2057400" cy="502920"/>
           </a:xfrm>
           <a:prstGeom prst="rect">
             <a:avLst/>
@@ -3378,77 +3636,40 @@
           <a:noFill/>
         </p:spPr>
         <p:txBody>
-          <a:bodyPr wrap="square" anchor="ctr">
+          <a:bodyPr wrap="square" anchor="ctr" lIns="101600" rIns="101600">
             <a:spAutoFit/>
           </a:bodyPr>
           <a:lstStyle/>
           <a:p>
             <a:pPr algn="ctr"/>
             <a:r>
-              <a:rPr sz="1600" b="0">
+              <a:rPr sz="1400" b="0">
                 <a:solidFill>
-                  <a:srgbClr val="FFFFFF"/>
+                  <a:srgbClr val="DBEAFE"/>
                 </a:solidFill>
                 <a:latin typeface="B Nazanin"/>
               </a:rPr>
-              <a:t>تعیین اهمیت نسبی</a:t>
-            </a:r>
-          </a:p>
-        </p:txBody>
-      </p:sp>
-      <p:sp>
-        <p:nvSpPr>
-          <p:cNvPr id="10" name="TextBox 9"/>
-          <p:cNvSpPr txBox="1"/>
+              <a:t>تعیین اهمیت نسبی معیارها</a:t>
+            </a:r>
+          </a:p>
+        </p:txBody>
+      </p:sp>
+      <p:sp>
+        <p:nvSpPr>
+          <p:cNvPr id="16" name="Rectangle 15"/>
+          <p:cNvSpPr/>
           <p:nvPr/>
         </p:nvSpPr>
         <p:spPr>
           <a:xfrm>
-            <a:off x="6355080" y="3566160"/>
-            <a:ext cx="1965960" cy="292608"/>
+            <a:off x="4901184" y="2779776"/>
+            <a:ext cx="2057400" cy="1600200"/>
           </a:xfrm>
           <a:prstGeom prst="rect">
             <a:avLst/>
           </a:prstGeom>
-          <a:noFill/>
-        </p:spPr>
-        <p:txBody>
-          <a:bodyPr wrap="square" anchor="ctr">
-            <a:spAutoFit/>
-          </a:bodyPr>
-          <a:lstStyle/>
-          <a:p>
-            <a:pPr algn="ctr"/>
-            <a:r>
-              <a:rPr sz="1600" b="0">
-                <a:solidFill>
-                  <a:srgbClr val="FFFFFF"/>
-                </a:solidFill>
-                <a:latin typeface="B Nazanin"/>
-              </a:rPr>
-              <a:t>معیارها</a:t>
-            </a:r>
-          </a:p>
-        </p:txBody>
-      </p:sp>
-      <p:sp>
-        <p:nvSpPr>
-          <p:cNvPr id="11" name="Rounded Rectangle 10"/>
-          <p:cNvSpPr/>
-          <p:nvPr/>
-        </p:nvSpPr>
-        <p:spPr>
-          <a:xfrm>
-            <a:off x="3977639" y="2423160"/>
-            <a:ext cx="1965960" cy="1645920"/>
-          </a:xfrm>
-          <a:prstGeom prst="roundRect">
-            <a:avLst>
-              <a:gd name="adj" fmla="val 8000"/>
-            </a:avLst>
-          </a:prstGeom>
           <a:solidFill>
-            <a:srgbClr val="2F6FED"/>
+            <a:srgbClr val="D1D9E6"/>
           </a:solidFill>
           <a:ln>
             <a:noFill/>
@@ -3478,14 +3699,102 @@
       </p:sp>
       <p:sp>
         <p:nvSpPr>
-          <p:cNvPr id="12" name="TextBox 11"/>
+          <p:cNvPr id="17" name="Rectangle 16"/>
+          <p:cNvSpPr/>
+          <p:nvPr/>
+        </p:nvSpPr>
+        <p:spPr>
+          <a:xfrm>
+            <a:off x="4864608" y="2743200"/>
+            <a:ext cx="2057400" cy="1600200"/>
+          </a:xfrm>
+          <a:prstGeom prst="rect">
+            <a:avLst/>
+          </a:prstGeom>
+          <a:solidFill>
+            <a:srgbClr val="2563EB"/>
+          </a:solidFill>
+          <a:ln w="9525">
+            <a:solidFill>
+              <a:srgbClr val="1E40AF"/>
+            </a:solidFill>
+          </a:ln>
+        </p:spPr>
+        <p:style>
+          <a:lnRef idx="1">
+            <a:schemeClr val="accent1"/>
+          </a:lnRef>
+          <a:fillRef idx="3">
+            <a:schemeClr val="accent1"/>
+          </a:fillRef>
+          <a:effectRef idx="2">
+            <a:schemeClr val="accent1"/>
+          </a:effectRef>
+          <a:fontRef idx="minor">
+            <a:schemeClr val="lt1"/>
+          </a:fontRef>
+        </p:style>
+        <p:txBody>
+          <a:bodyPr rtlCol="0" anchor="ctr"/>
+          <a:lstStyle/>
+          <a:p>
+            <a:pPr algn="ctr"/>
+          </a:p>
+        </p:txBody>
+      </p:sp>
+      <p:sp>
+        <p:nvSpPr>
+          <p:cNvPr id="18" name="Rectangle 17"/>
+          <p:cNvSpPr/>
+          <p:nvPr/>
+        </p:nvSpPr>
+        <p:spPr>
+          <a:xfrm>
+            <a:off x="4864608" y="2743200"/>
+            <a:ext cx="2057400" cy="45720"/>
+          </a:xfrm>
+          <a:prstGeom prst="rect">
+            <a:avLst/>
+          </a:prstGeom>
+          <a:solidFill>
+            <a:srgbClr val="60A5FA"/>
+          </a:solidFill>
+          <a:ln>
+            <a:noFill/>
+          </a:ln>
+        </p:spPr>
+        <p:style>
+          <a:lnRef idx="1">
+            <a:schemeClr val="accent1"/>
+          </a:lnRef>
+          <a:fillRef idx="3">
+            <a:schemeClr val="accent1"/>
+          </a:fillRef>
+          <a:effectRef idx="2">
+            <a:schemeClr val="accent1"/>
+          </a:effectRef>
+          <a:fontRef idx="minor">
+            <a:schemeClr val="lt1"/>
+          </a:fontRef>
+        </p:style>
+        <p:txBody>
+          <a:bodyPr rtlCol="0" anchor="ctr"/>
+          <a:lstStyle/>
+          <a:p>
+            <a:pPr algn="ctr"/>
+          </a:p>
+        </p:txBody>
+      </p:sp>
+      <p:sp>
+        <p:nvSpPr>
+          <p:cNvPr id="19" name="TextBox 18"/>
           <p:cNvSpPr txBox="1"/>
           <p:nvPr/>
         </p:nvSpPr>
         <p:spPr>
           <a:xfrm>
-            <a:off x="3977639" y="2834640"/>
-            <a:ext cx="1965960" cy="365760"/>
+            <a:off x="4864608" y="3044952"/>
+            <a:ext cx="2057400" cy="384048"/>
           </a:xfrm>
           <a:prstGeom prst="rect">
             <a:avLst/>
@@ -3493,14 +3802,14 @@
           <a:noFill/>
         </p:spPr>
         <p:txBody>
-          <a:bodyPr wrap="square" anchor="ctr">
+          <a:bodyPr wrap="square" anchor="ctr" lIns="101600" rIns="101600">
             <a:spAutoFit/>
           </a:bodyPr>
           <a:lstStyle/>
           <a:p>
             <a:pPr algn="ctr"/>
             <a:r>
-              <a:rPr sz="2200" b="1">
+              <a:rPr sz="2000" b="1">
                 <a:solidFill>
                   <a:srgbClr val="FFFFFF"/>
                 </a:solidFill>
@@ -3513,14 +3822,14 @@
       </p:sp>
       <p:sp>
         <p:nvSpPr>
-          <p:cNvPr id="13" name="TextBox 12"/>
+          <p:cNvPr id="20" name="TextBox 19"/>
           <p:cNvSpPr txBox="1"/>
           <p:nvPr/>
         </p:nvSpPr>
         <p:spPr>
           <a:xfrm>
-            <a:off x="3977639" y="3291840"/>
-            <a:ext cx="1965960" cy="292608"/>
+            <a:off x="4864608" y="3447288"/>
+            <a:ext cx="2057400" cy="502920"/>
           </a:xfrm>
           <a:prstGeom prst="rect">
             <a:avLst/>
@@ -3528,77 +3837,40 @@
           <a:noFill/>
         </p:spPr>
         <p:txBody>
-          <a:bodyPr wrap="square" anchor="ctr">
+          <a:bodyPr wrap="square" anchor="ctr" lIns="101600" rIns="101600">
             <a:spAutoFit/>
           </a:bodyPr>
           <a:lstStyle/>
           <a:p>
             <a:pPr algn="ctr"/>
             <a:r>
-              <a:rPr sz="1600" b="0">
+              <a:rPr sz="1400" b="0">
                 <a:solidFill>
-                  <a:srgbClr val="FFFFFF"/>
+                  <a:srgbClr val="DBEAFE"/>
                 </a:solidFill>
                 <a:latin typeface="B Nazanin"/>
               </a:rPr>
-              <a:t>تطبیق وزن‌ها با</a:t>
-            </a:r>
-          </a:p>
-        </p:txBody>
-      </p:sp>
-      <p:sp>
-        <p:nvSpPr>
-          <p:cNvPr id="14" name="TextBox 13"/>
-          <p:cNvSpPr txBox="1"/>
+              <a:t>تطبیق وزن‌ها با سناریوی پروژه</a:t>
+            </a:r>
+          </a:p>
+        </p:txBody>
+      </p:sp>
+      <p:sp>
+        <p:nvSpPr>
+          <p:cNvPr id="21" name="Rectangle 20"/>
+          <p:cNvSpPr/>
           <p:nvPr/>
         </p:nvSpPr>
         <p:spPr>
           <a:xfrm>
-            <a:off x="3977639" y="3566160"/>
-            <a:ext cx="1965960" cy="292608"/>
+            <a:off x="2496312" y="2779776"/>
+            <a:ext cx="2057400" cy="1600200"/>
           </a:xfrm>
           <a:prstGeom prst="rect">
             <a:avLst/>
           </a:prstGeom>
-          <a:noFill/>
-        </p:spPr>
-        <p:txBody>
-          <a:bodyPr wrap="square" anchor="ctr">
-            <a:spAutoFit/>
-          </a:bodyPr>
-          <a:lstStyle/>
-          <a:p>
-            <a:pPr algn="ctr"/>
-            <a:r>
-              <a:rPr sz="1600" b="0">
-                <a:solidFill>
-                  <a:srgbClr val="FFFFFF"/>
-                </a:solidFill>
-                <a:latin typeface="B Nazanin"/>
-              </a:rPr>
-              <a:t>سناریوی پروژه</a:t>
-            </a:r>
-          </a:p>
-        </p:txBody>
-      </p:sp>
-      <p:sp>
-        <p:nvSpPr>
-          <p:cNvPr id="15" name="Rounded Rectangle 14"/>
-          <p:cNvSpPr/>
-          <p:nvPr/>
-        </p:nvSpPr>
-        <p:spPr>
-          <a:xfrm>
-            <a:off x="1600200" y="2423160"/>
-            <a:ext cx="1965960" cy="1645920"/>
-          </a:xfrm>
-          <a:prstGeom prst="roundRect">
-            <a:avLst>
-              <a:gd name="adj" fmla="val 8000"/>
-            </a:avLst>
-          </a:prstGeom>
           <a:solidFill>
-            <a:srgbClr val="2F6FED"/>
+            <a:srgbClr val="D1D9E6"/>
           </a:solidFill>
           <a:ln>
             <a:noFill/>
@@ -3628,14 +3900,102 @@
       </p:sp>
       <p:sp>
         <p:nvSpPr>
-          <p:cNvPr id="16" name="TextBox 15"/>
+          <p:cNvPr id="22" name="Rectangle 21"/>
+          <p:cNvSpPr/>
+          <p:nvPr/>
+        </p:nvSpPr>
+        <p:spPr>
+          <a:xfrm>
+            <a:off x="2459736" y="2743200"/>
+            <a:ext cx="2057400" cy="1600200"/>
+          </a:xfrm>
+          <a:prstGeom prst="rect">
+            <a:avLst/>
+          </a:prstGeom>
+          <a:solidFill>
+            <a:srgbClr val="2563EB"/>
+          </a:solidFill>
+          <a:ln w="9525">
+            <a:solidFill>
+              <a:srgbClr val="1E40AF"/>
+            </a:solidFill>
+          </a:ln>
+        </p:spPr>
+        <p:style>
+          <a:lnRef idx="1">
+            <a:schemeClr val="accent1"/>
+          </a:lnRef>
+          <a:fillRef idx="3">
+            <a:schemeClr val="accent1"/>
+          </a:fillRef>
+          <a:effectRef idx="2">
+            <a:schemeClr val="accent1"/>
+          </a:effectRef>
+          <a:fontRef idx="minor">
+            <a:schemeClr val="lt1"/>
+          </a:fontRef>
+        </p:style>
+        <p:txBody>
+          <a:bodyPr rtlCol="0" anchor="ctr"/>
+          <a:lstStyle/>
+          <a:p>
+            <a:pPr algn="ctr"/>
+          </a:p>
+        </p:txBody>
+      </p:sp>
+      <p:sp>
+        <p:nvSpPr>
+          <p:cNvPr id="23" name="Rectangle 22"/>
+          <p:cNvSpPr/>
+          <p:nvPr/>
+        </p:nvSpPr>
+        <p:spPr>
+          <a:xfrm>
+            <a:off x="2459736" y="2743200"/>
+            <a:ext cx="2057400" cy="45720"/>
+          </a:xfrm>
+          <a:prstGeom prst="rect">
+            <a:avLst/>
+          </a:prstGeom>
+          <a:solidFill>
+            <a:srgbClr val="60A5FA"/>
+          </a:solidFill>
+          <a:ln>
+            <a:noFill/>
+          </a:ln>
+        </p:spPr>
+        <p:style>
+          <a:lnRef idx="1">
+            <a:schemeClr val="accent1"/>
+          </a:lnRef>
+          <a:fillRef idx="3">
+            <a:schemeClr val="accent1"/>
+          </a:fillRef>
+          <a:effectRef idx="2">
+            <a:schemeClr val="accent1"/>
+          </a:effectRef>
+          <a:fontRef idx="minor">
+            <a:schemeClr val="lt1"/>
+          </a:fontRef>
+        </p:style>
+        <p:txBody>
+          <a:bodyPr rtlCol="0" anchor="ctr"/>
+          <a:lstStyle/>
+          <a:p>
+            <a:pPr algn="ctr"/>
+          </a:p>
+        </p:txBody>
+      </p:sp>
+      <p:sp>
+        <p:nvSpPr>
+          <p:cNvPr id="24" name="TextBox 23"/>
           <p:cNvSpPr txBox="1"/>
           <p:nvPr/>
         </p:nvSpPr>
         <p:spPr>
           <a:xfrm>
-            <a:off x="1600200" y="2834640"/>
-            <a:ext cx="1965960" cy="365760"/>
+            <a:off x="2459736" y="3044952"/>
+            <a:ext cx="2057400" cy="384048"/>
           </a:xfrm>
           <a:prstGeom prst="rect">
             <a:avLst/>
@@ -3643,7 +4003,7 @@
           <a:noFill/>
         </p:spPr>
         <p:txBody>
-          <a:bodyPr wrap="square" anchor="ctr">
+          <a:bodyPr wrap="square" anchor="ctr" lIns="101600" rIns="101600">
             <a:spAutoFit/>
           </a:bodyPr>
           <a:lstStyle/>
@@ -3663,14 +4023,14 @@
       </p:sp>
       <p:sp>
         <p:nvSpPr>
-          <p:cNvPr id="17" name="TextBox 16"/>
+          <p:cNvPr id="25" name="TextBox 24"/>
           <p:cNvSpPr txBox="1"/>
           <p:nvPr/>
         </p:nvSpPr>
         <p:spPr>
           <a:xfrm>
-            <a:off x="1600200" y="3291840"/>
-            <a:ext cx="1965960" cy="292608"/>
+            <a:off x="2459736" y="3447288"/>
+            <a:ext cx="2057400" cy="502920"/>
           </a:xfrm>
           <a:prstGeom prst="rect">
             <a:avLst/>
@@ -3678,34 +4038,200 @@
           <a:noFill/>
         </p:spPr>
         <p:txBody>
-          <a:bodyPr wrap="square" anchor="ctr">
+          <a:bodyPr wrap="square" anchor="ctr" lIns="101600" rIns="101600">
             <a:spAutoFit/>
           </a:bodyPr>
           <a:lstStyle/>
           <a:p>
             <a:pPr algn="ctr"/>
             <a:r>
-              <a:rPr sz="1600" b="0">
+              <a:rPr sz="1400" b="0">
+                <a:solidFill>
+                  <a:srgbClr val="DBEAFE"/>
+                </a:solidFill>
+                <a:latin typeface="B Nazanin"/>
+              </a:rPr>
+              <a:t>رتبه‌بندی نهایی در خوشه منتخب</a:t>
+            </a:r>
+          </a:p>
+        </p:txBody>
+      </p:sp>
+      <p:sp>
+        <p:nvSpPr>
+          <p:cNvPr id="26" name="Rectangle 25"/>
+          <p:cNvSpPr/>
+          <p:nvPr/>
+        </p:nvSpPr>
+        <p:spPr>
+          <a:xfrm>
+            <a:off x="822960" y="2916936"/>
+            <a:ext cx="1325880" cy="1325880"/>
+          </a:xfrm>
+          <a:prstGeom prst="rect">
+            <a:avLst/>
+          </a:prstGeom>
+          <a:solidFill>
+            <a:srgbClr val="D1D9E6"/>
+          </a:solidFill>
+          <a:ln>
+            <a:noFill/>
+          </a:ln>
+        </p:spPr>
+        <p:style>
+          <a:lnRef idx="1">
+            <a:schemeClr val="accent1"/>
+          </a:lnRef>
+          <a:fillRef idx="3">
+            <a:schemeClr val="accent1"/>
+          </a:fillRef>
+          <a:effectRef idx="2">
+            <a:schemeClr val="accent1"/>
+          </a:effectRef>
+          <a:fontRef idx="minor">
+            <a:schemeClr val="lt1"/>
+          </a:fontRef>
+        </p:style>
+        <p:txBody>
+          <a:bodyPr rtlCol="0" anchor="ctr"/>
+          <a:lstStyle/>
+          <a:p>
+            <a:pPr algn="ctr"/>
+          </a:p>
+        </p:txBody>
+      </p:sp>
+      <p:sp>
+        <p:nvSpPr>
+          <p:cNvPr id="27" name="Rectangle 26"/>
+          <p:cNvSpPr/>
+          <p:nvPr/>
+        </p:nvSpPr>
+        <p:spPr>
+          <a:xfrm>
+            <a:off x="786384" y="2880360"/>
+            <a:ext cx="1325880" cy="1325880"/>
+          </a:xfrm>
+          <a:prstGeom prst="rect">
+            <a:avLst/>
+          </a:prstGeom>
+          <a:solidFill>
+            <a:srgbClr val="1E40AF"/>
+          </a:solidFill>
+          <a:ln w="9525">
+            <a:solidFill>
+              <a:srgbClr val="1E40AF"/>
+            </a:solidFill>
+          </a:ln>
+        </p:spPr>
+        <p:style>
+          <a:lnRef idx="1">
+            <a:schemeClr val="accent1"/>
+          </a:lnRef>
+          <a:fillRef idx="3">
+            <a:schemeClr val="accent1"/>
+          </a:fillRef>
+          <a:effectRef idx="2">
+            <a:schemeClr val="accent1"/>
+          </a:effectRef>
+          <a:fontRef idx="minor">
+            <a:schemeClr val="lt1"/>
+          </a:fontRef>
+        </p:style>
+        <p:txBody>
+          <a:bodyPr rtlCol="0" anchor="ctr"/>
+          <a:lstStyle/>
+          <a:p>
+            <a:pPr algn="ctr"/>
+          </a:p>
+        </p:txBody>
+      </p:sp>
+      <p:sp>
+        <p:nvSpPr>
+          <p:cNvPr id="28" name="Rectangle 27"/>
+          <p:cNvSpPr/>
+          <p:nvPr/>
+        </p:nvSpPr>
+        <p:spPr>
+          <a:xfrm>
+            <a:off x="786384" y="2880360"/>
+            <a:ext cx="1325880" cy="45720"/>
+          </a:xfrm>
+          <a:prstGeom prst="rect">
+            <a:avLst/>
+          </a:prstGeom>
+          <a:solidFill>
+            <a:srgbClr val="60A5FA"/>
+          </a:solidFill>
+          <a:ln>
+            <a:noFill/>
+          </a:ln>
+        </p:spPr>
+        <p:style>
+          <a:lnRef idx="1">
+            <a:schemeClr val="accent1"/>
+          </a:lnRef>
+          <a:fillRef idx="3">
+            <a:schemeClr val="accent1"/>
+          </a:fillRef>
+          <a:effectRef idx="2">
+            <a:schemeClr val="accent1"/>
+          </a:effectRef>
+          <a:fontRef idx="minor">
+            <a:schemeClr val="lt1"/>
+          </a:fontRef>
+        </p:style>
+        <p:txBody>
+          <a:bodyPr rtlCol="0" anchor="ctr"/>
+          <a:lstStyle/>
+          <a:p>
+            <a:pPr algn="ctr"/>
+          </a:p>
+        </p:txBody>
+      </p:sp>
+      <p:sp>
+        <p:nvSpPr>
+          <p:cNvPr id="29" name="TextBox 28"/>
+          <p:cNvSpPr txBox="1"/>
+          <p:nvPr/>
+        </p:nvSpPr>
+        <p:spPr>
+          <a:xfrm>
+            <a:off x="786384" y="3182112"/>
+            <a:ext cx="1325880" cy="384048"/>
+          </a:xfrm>
+          <a:prstGeom prst="rect">
+            <a:avLst/>
+          </a:prstGeom>
+          <a:noFill/>
+        </p:spPr>
+        <p:txBody>
+          <a:bodyPr wrap="square" anchor="ctr" lIns="101600" rIns="101600">
+            <a:spAutoFit/>
+          </a:bodyPr>
+          <a:lstStyle/>
+          <a:p>
+            <a:pPr algn="ctr"/>
+            <a:r>
+              <a:rPr sz="2000" b="1">
                 <a:solidFill>
                   <a:srgbClr val="FFFFFF"/>
                 </a:solidFill>
                 <a:latin typeface="B Nazanin"/>
               </a:rPr>
-              <a:t>رتبه‌بندی نهایی در</a:t>
-            </a:r>
-          </a:p>
-        </p:txBody>
-      </p:sp>
-      <p:sp>
-        <p:nvSpPr>
-          <p:cNvPr id="18" name="TextBox 17"/>
+              <a:t>فناوری منتخب</a:t>
+            </a:r>
+          </a:p>
+        </p:txBody>
+      </p:sp>
+      <p:sp>
+        <p:nvSpPr>
+          <p:cNvPr id="30" name="TextBox 29"/>
           <p:cNvSpPr txBox="1"/>
           <p:nvPr/>
         </p:nvSpPr>
         <p:spPr>
           <a:xfrm>
-            <a:off x="1600200" y="3566160"/>
-            <a:ext cx="1965960" cy="292608"/>
+            <a:off x="786384" y="3584448"/>
+            <a:ext cx="1325880" cy="502920"/>
           </a:xfrm>
           <a:prstGeom prst="rect">
             <a:avLst/>
@@ -3713,42 +4239,40 @@
           <a:noFill/>
         </p:spPr>
         <p:txBody>
-          <a:bodyPr wrap="square" anchor="ctr">
+          <a:bodyPr wrap="square" anchor="ctr" lIns="101600" rIns="101600">
             <a:spAutoFit/>
           </a:bodyPr>
           <a:lstStyle/>
           <a:p>
             <a:pPr algn="ctr"/>
             <a:r>
-              <a:rPr sz="1600" b="0">
+              <a:rPr sz="1300" b="0">
                 <a:solidFill>
-                  <a:srgbClr val="FFFFFF"/>
+                  <a:srgbClr val="DBEAFE"/>
                 </a:solidFill>
                 <a:latin typeface="B Nazanin"/>
               </a:rPr>
-              <a:t>خوشه منتخب</a:t>
-            </a:r>
-          </a:p>
-        </p:txBody>
-      </p:sp>
-      <p:sp>
-        <p:nvSpPr>
-          <p:cNvPr id="19" name="Rounded Rectangle 18"/>
+              <a:t>خروجی نهایی</a:t>
+            </a:r>
+          </a:p>
+        </p:txBody>
+      </p:sp>
+      <p:sp>
+        <p:nvSpPr>
+          <p:cNvPr id="31" name="Chevron 30"/>
           <p:cNvSpPr/>
           <p:nvPr/>
         </p:nvSpPr>
         <p:spPr>
-          <a:xfrm>
-            <a:off x="228600" y="2651760"/>
-            <a:ext cx="1234440" cy="1188720"/>
-          </a:xfrm>
-          <a:prstGeom prst="roundRect">
-            <a:avLst>
-              <a:gd name="adj" fmla="val 8000"/>
-            </a:avLst>
+          <a:xfrm rot="10800000">
+            <a:off x="9326880" y="3378708"/>
+            <a:ext cx="347472" cy="329184"/>
+          </a:xfrm>
+          <a:prstGeom prst="chevron">
+            <a:avLst/>
           </a:prstGeom>
           <a:solidFill>
-            <a:srgbClr val="2F6FED"/>
+            <a:srgbClr val="94A3B8"/>
           </a:solidFill>
           <a:ln>
             <a:noFill/>
@@ -3778,90 +4302,20 @@
       </p:sp>
       <p:sp>
         <p:nvSpPr>
-          <p:cNvPr id="20" name="TextBox 19"/>
-          <p:cNvSpPr txBox="1"/>
-          <p:nvPr/>
-        </p:nvSpPr>
-        <p:spPr>
-          <a:xfrm>
-            <a:off x="228600" y="2926080"/>
-            <a:ext cx="1234440" cy="320040"/>
-          </a:xfrm>
-          <a:prstGeom prst="rect">
-            <a:avLst/>
-          </a:prstGeom>
-          <a:noFill/>
-        </p:spPr>
-        <p:txBody>
-          <a:bodyPr wrap="square" anchor="ctr">
-            <a:spAutoFit/>
-          </a:bodyPr>
-          <a:lstStyle/>
-          <a:p>
-            <a:pPr algn="ctr"/>
-            <a:r>
-              <a:rPr sz="1800" b="1">
-                <a:solidFill>
-                  <a:srgbClr val="FFFFFF"/>
-                </a:solidFill>
-                <a:latin typeface="B Nazanin"/>
-              </a:rPr>
-              <a:t>فناوری</a:t>
-            </a:r>
-          </a:p>
-        </p:txBody>
-      </p:sp>
-      <p:sp>
-        <p:nvSpPr>
-          <p:cNvPr id="21" name="TextBox 20"/>
-          <p:cNvSpPr txBox="1"/>
-          <p:nvPr/>
-        </p:nvSpPr>
-        <p:spPr>
-          <a:xfrm>
-            <a:off x="228600" y="3218688"/>
-            <a:ext cx="1234440" cy="320040"/>
-          </a:xfrm>
-          <a:prstGeom prst="rect">
-            <a:avLst/>
-          </a:prstGeom>
-          <a:noFill/>
-        </p:spPr>
-        <p:txBody>
-          <a:bodyPr wrap="square" anchor="ctr">
-            <a:spAutoFit/>
-          </a:bodyPr>
-          <a:lstStyle/>
-          <a:p>
-            <a:pPr algn="ctr"/>
-            <a:r>
-              <a:rPr sz="1800" b="1">
-                <a:solidFill>
-                  <a:srgbClr val="FFFFFF"/>
-                </a:solidFill>
-                <a:latin typeface="B Nazanin"/>
-              </a:rPr>
-              <a:t>منتخب</a:t>
-            </a:r>
-          </a:p>
-        </p:txBody>
-      </p:sp>
-      <p:sp>
-        <p:nvSpPr>
-          <p:cNvPr id="22" name="Right Arrow 21"/>
+          <p:cNvPr id="32" name="Chevron 31"/>
           <p:cNvSpPr/>
           <p:nvPr/>
         </p:nvSpPr>
         <p:spPr>
-          <a:xfrm>
-            <a:off x="8549640" y="3108960"/>
-            <a:ext cx="502920" cy="274320"/>
-          </a:xfrm>
-          <a:prstGeom prst="rightArrow">
+          <a:xfrm rot="10800000">
+            <a:off x="6922008" y="3378708"/>
+            <a:ext cx="347472" cy="329184"/>
+          </a:xfrm>
+          <a:prstGeom prst="chevron">
             <a:avLst/>
           </a:prstGeom>
           <a:solidFill>
-            <a:srgbClr val="4A4A4A"/>
+            <a:srgbClr val="94A3B8"/>
           </a:solidFill>
           <a:ln>
             <a:noFill/>
@@ -3891,20 +4345,20 @@
       </p:sp>
       <p:sp>
         <p:nvSpPr>
-          <p:cNvPr id="23" name="Right Arrow 22"/>
+          <p:cNvPr id="33" name="Chevron 32"/>
           <p:cNvSpPr/>
           <p:nvPr/>
         </p:nvSpPr>
         <p:spPr>
-          <a:xfrm>
-            <a:off x="6172200" y="3108960"/>
-            <a:ext cx="502920" cy="274320"/>
-          </a:xfrm>
-          <a:prstGeom prst="rightArrow">
+          <a:xfrm rot="10800000">
+            <a:off x="4517136" y="3378708"/>
+            <a:ext cx="347472" cy="329184"/>
+          </a:xfrm>
+          <a:prstGeom prst="chevron">
             <a:avLst/>
           </a:prstGeom>
           <a:solidFill>
-            <a:srgbClr val="4A4A4A"/>
+            <a:srgbClr val="94A3B8"/>
           </a:solidFill>
           <a:ln>
             <a:noFill/>
@@ -3934,20 +4388,20 @@
       </p:sp>
       <p:sp>
         <p:nvSpPr>
-          <p:cNvPr id="24" name="Right Arrow 23"/>
+          <p:cNvPr id="34" name="Chevron 33"/>
           <p:cNvSpPr/>
           <p:nvPr/>
         </p:nvSpPr>
         <p:spPr>
-          <a:xfrm>
-            <a:off x="3794760" y="3108960"/>
-            <a:ext cx="502920" cy="274320"/>
-          </a:xfrm>
-          <a:prstGeom prst="rightArrow">
+          <a:xfrm rot="10800000">
+            <a:off x="2112264" y="3378708"/>
+            <a:ext cx="347472" cy="329184"/>
+          </a:xfrm>
+          <a:prstGeom prst="chevron">
             <a:avLst/>
           </a:prstGeom>
           <a:solidFill>
-            <a:srgbClr val="4A4A4A"/>
+            <a:srgbClr val="94A3B8"/>
           </a:solidFill>
           <a:ln>
             <a:noFill/>
@@ -3977,23 +4431,25 @@
       </p:sp>
       <p:sp>
         <p:nvSpPr>
-          <p:cNvPr id="25" name="Right Arrow 24"/>
+          <p:cNvPr id="35" name="Oval 34"/>
           <p:cNvSpPr/>
           <p:nvPr/>
         </p:nvSpPr>
         <p:spPr>
           <a:xfrm>
-            <a:off x="1508760" y="3108960"/>
-            <a:ext cx="502920" cy="274320"/>
-          </a:xfrm>
-          <a:prstGeom prst="rightArrow">
+            <a:off x="11475720" y="2852928"/>
+            <a:ext cx="256032" cy="256032"/>
+          </a:xfrm>
+          <a:prstGeom prst="ellipse">
             <a:avLst/>
           </a:prstGeom>
           <a:solidFill>
-            <a:srgbClr val="4A4A4A"/>
+            <a:srgbClr val="FFFFFF"/>
           </a:solidFill>
-          <a:ln>
-            <a:noFill/>
+          <a:ln w="9525">
+            <a:solidFill>
+              <a:srgbClr val="1E40AF"/>
+            </a:solidFill>
           </a:ln>
         </p:spPr>
         <p:style>
@@ -4020,14 +4476,14 @@
       </p:sp>
       <p:sp>
         <p:nvSpPr>
-          <p:cNvPr id="26" name="TextBox 25"/>
+          <p:cNvPr id="36" name="TextBox 35"/>
           <p:cNvSpPr txBox="1"/>
           <p:nvPr/>
         </p:nvSpPr>
         <p:spPr>
           <a:xfrm>
-            <a:off x="457200" y="4937760"/>
-            <a:ext cx="11247120" cy="411480"/>
+            <a:off x="11475720" y="2852928"/>
+            <a:ext cx="256032" cy="256032"/>
           </a:xfrm>
           <a:prstGeom prst="rect">
             <a:avLst/>
@@ -4035,16 +4491,291 @@
           <a:noFill/>
         </p:spPr>
         <p:txBody>
-          <a:bodyPr wrap="square" anchor="ctr">
+          <a:bodyPr wrap="square" anchor="ctr" lIns="101600" rIns="101600">
             <a:spAutoFit/>
           </a:bodyPr>
           <a:lstStyle/>
           <a:p>
             <a:pPr algn="ctr"/>
             <a:r>
-              <a:rPr sz="1600" b="0">
+              <a:rPr sz="1100" b="1">
                 <a:solidFill>
-                  <a:srgbClr val="444444"/>
+                  <a:srgbClr val="1E40AF"/>
+                </a:solidFill>
+                <a:latin typeface="B Nazanin"/>
+              </a:rPr>
+              <a:t>۱</a:t>
+            </a:r>
+          </a:p>
+        </p:txBody>
+      </p:sp>
+      <p:sp>
+        <p:nvSpPr>
+          <p:cNvPr id="37" name="Oval 36"/>
+          <p:cNvSpPr/>
+          <p:nvPr/>
+        </p:nvSpPr>
+        <p:spPr>
+          <a:xfrm>
+            <a:off x="9070848" y="2852928"/>
+            <a:ext cx="256032" cy="256032"/>
+          </a:xfrm>
+          <a:prstGeom prst="ellipse">
+            <a:avLst/>
+          </a:prstGeom>
+          <a:solidFill>
+            <a:srgbClr val="FFFFFF"/>
+          </a:solidFill>
+          <a:ln w="9525">
+            <a:solidFill>
+              <a:srgbClr val="1E40AF"/>
+            </a:solidFill>
+          </a:ln>
+        </p:spPr>
+        <p:style>
+          <a:lnRef idx="1">
+            <a:schemeClr val="accent1"/>
+          </a:lnRef>
+          <a:fillRef idx="3">
+            <a:schemeClr val="accent1"/>
+          </a:fillRef>
+          <a:effectRef idx="2">
+            <a:schemeClr val="accent1"/>
+          </a:effectRef>
+          <a:fontRef idx="minor">
+            <a:schemeClr val="lt1"/>
+          </a:fontRef>
+        </p:style>
+        <p:txBody>
+          <a:bodyPr rtlCol="0" anchor="ctr"/>
+          <a:lstStyle/>
+          <a:p>
+            <a:pPr algn="ctr"/>
+          </a:p>
+        </p:txBody>
+      </p:sp>
+      <p:sp>
+        <p:nvSpPr>
+          <p:cNvPr id="38" name="TextBox 37"/>
+          <p:cNvSpPr txBox="1"/>
+          <p:nvPr/>
+        </p:nvSpPr>
+        <p:spPr>
+          <a:xfrm>
+            <a:off x="9070848" y="2852928"/>
+            <a:ext cx="256032" cy="256032"/>
+          </a:xfrm>
+          <a:prstGeom prst="rect">
+            <a:avLst/>
+          </a:prstGeom>
+          <a:noFill/>
+        </p:spPr>
+        <p:txBody>
+          <a:bodyPr wrap="square" anchor="ctr" lIns="101600" rIns="101600">
+            <a:spAutoFit/>
+          </a:bodyPr>
+          <a:lstStyle/>
+          <a:p>
+            <a:pPr algn="ctr"/>
+            <a:r>
+              <a:rPr sz="1100" b="1">
+                <a:solidFill>
+                  <a:srgbClr val="1E40AF"/>
+                </a:solidFill>
+                <a:latin typeface="B Nazanin"/>
+              </a:rPr>
+              <a:t>۲</a:t>
+            </a:r>
+          </a:p>
+        </p:txBody>
+      </p:sp>
+      <p:sp>
+        <p:nvSpPr>
+          <p:cNvPr id="39" name="Oval 38"/>
+          <p:cNvSpPr/>
+          <p:nvPr/>
+        </p:nvSpPr>
+        <p:spPr>
+          <a:xfrm>
+            <a:off x="6665976" y="2852928"/>
+            <a:ext cx="256032" cy="256032"/>
+          </a:xfrm>
+          <a:prstGeom prst="ellipse">
+            <a:avLst/>
+          </a:prstGeom>
+          <a:solidFill>
+            <a:srgbClr val="FFFFFF"/>
+          </a:solidFill>
+          <a:ln w="9525">
+            <a:solidFill>
+              <a:srgbClr val="1E40AF"/>
+            </a:solidFill>
+          </a:ln>
+        </p:spPr>
+        <p:style>
+          <a:lnRef idx="1">
+            <a:schemeClr val="accent1"/>
+          </a:lnRef>
+          <a:fillRef idx="3">
+            <a:schemeClr val="accent1"/>
+          </a:fillRef>
+          <a:effectRef idx="2">
+            <a:schemeClr val="accent1"/>
+          </a:effectRef>
+          <a:fontRef idx="minor">
+            <a:schemeClr val="lt1"/>
+          </a:fontRef>
+        </p:style>
+        <p:txBody>
+          <a:bodyPr rtlCol="0" anchor="ctr"/>
+          <a:lstStyle/>
+          <a:p>
+            <a:pPr algn="ctr"/>
+          </a:p>
+        </p:txBody>
+      </p:sp>
+      <p:sp>
+        <p:nvSpPr>
+          <p:cNvPr id="40" name="TextBox 39"/>
+          <p:cNvSpPr txBox="1"/>
+          <p:nvPr/>
+        </p:nvSpPr>
+        <p:spPr>
+          <a:xfrm>
+            <a:off x="6665976" y="2852928"/>
+            <a:ext cx="256032" cy="256032"/>
+          </a:xfrm>
+          <a:prstGeom prst="rect">
+            <a:avLst/>
+          </a:prstGeom>
+          <a:noFill/>
+        </p:spPr>
+        <p:txBody>
+          <a:bodyPr wrap="square" anchor="ctr" lIns="101600" rIns="101600">
+            <a:spAutoFit/>
+          </a:bodyPr>
+          <a:lstStyle/>
+          <a:p>
+            <a:pPr algn="ctr"/>
+            <a:r>
+              <a:rPr sz="1100" b="1">
+                <a:solidFill>
+                  <a:srgbClr val="1E40AF"/>
+                </a:solidFill>
+                <a:latin typeface="B Nazanin"/>
+              </a:rPr>
+              <a:t>۳</a:t>
+            </a:r>
+          </a:p>
+        </p:txBody>
+      </p:sp>
+      <p:sp>
+        <p:nvSpPr>
+          <p:cNvPr id="41" name="Oval 40"/>
+          <p:cNvSpPr/>
+          <p:nvPr/>
+        </p:nvSpPr>
+        <p:spPr>
+          <a:xfrm>
+            <a:off x="4261104" y="2852928"/>
+            <a:ext cx="256032" cy="256032"/>
+          </a:xfrm>
+          <a:prstGeom prst="ellipse">
+            <a:avLst/>
+          </a:prstGeom>
+          <a:solidFill>
+            <a:srgbClr val="FFFFFF"/>
+          </a:solidFill>
+          <a:ln w="9525">
+            <a:solidFill>
+              <a:srgbClr val="1E40AF"/>
+            </a:solidFill>
+          </a:ln>
+        </p:spPr>
+        <p:style>
+          <a:lnRef idx="1">
+            <a:schemeClr val="accent1"/>
+          </a:lnRef>
+          <a:fillRef idx="3">
+            <a:schemeClr val="accent1"/>
+          </a:fillRef>
+          <a:effectRef idx="2">
+            <a:schemeClr val="accent1"/>
+          </a:effectRef>
+          <a:fontRef idx="minor">
+            <a:schemeClr val="lt1"/>
+          </a:fontRef>
+        </p:style>
+        <p:txBody>
+          <a:bodyPr rtlCol="0" anchor="ctr"/>
+          <a:lstStyle/>
+          <a:p>
+            <a:pPr algn="ctr"/>
+          </a:p>
+        </p:txBody>
+      </p:sp>
+      <p:sp>
+        <p:nvSpPr>
+          <p:cNvPr id="42" name="TextBox 41"/>
+          <p:cNvSpPr txBox="1"/>
+          <p:nvPr/>
+        </p:nvSpPr>
+        <p:spPr>
+          <a:xfrm>
+            <a:off x="4261104" y="2852928"/>
+            <a:ext cx="256032" cy="256032"/>
+          </a:xfrm>
+          <a:prstGeom prst="rect">
+            <a:avLst/>
+          </a:prstGeom>
+          <a:noFill/>
+        </p:spPr>
+        <p:txBody>
+          <a:bodyPr wrap="square" anchor="ctr" lIns="101600" rIns="101600">
+            <a:spAutoFit/>
+          </a:bodyPr>
+          <a:lstStyle/>
+          <a:p>
+            <a:pPr algn="ctr"/>
+            <a:r>
+              <a:rPr sz="1100" b="1">
+                <a:solidFill>
+                  <a:srgbClr val="1E40AF"/>
+                </a:solidFill>
+                <a:latin typeface="B Nazanin"/>
+              </a:rPr>
+              <a:t>۴</a:t>
+            </a:r>
+          </a:p>
+        </p:txBody>
+      </p:sp>
+      <p:sp>
+        <p:nvSpPr>
+          <p:cNvPr id="43" name="TextBox 42"/>
+          <p:cNvSpPr txBox="1"/>
+          <p:nvPr/>
+        </p:nvSpPr>
+        <p:spPr>
+          <a:xfrm>
+            <a:off x="731520" y="4892040"/>
+            <a:ext cx="10725912" cy="365760"/>
+          </a:xfrm>
+          <a:prstGeom prst="rect">
+            <a:avLst/>
+          </a:prstGeom>
+          <a:noFill/>
+        </p:spPr>
+        <p:txBody>
+          <a:bodyPr wrap="square" anchor="ctr" lIns="101600" rIns="101600">
+            <a:spAutoFit/>
+          </a:bodyPr>
+          <a:lstStyle/>
+          <a:p>
+            <a:pPr algn="ctr"/>
+            <a:r>
+              <a:rPr sz="1500" b="0">
+                <a:solidFill>
+                  <a:srgbClr val="64748B"/>
                 </a:solidFill>
                 <a:latin typeface="B Nazanin"/>
               </a:rPr>

</xml_diff>